<commit_message>
manuscript results section edits
</commit_message>
<xml_diff>
--- a/ZenabuPhD/COMMUNITY PROTECTION/PRESENTATIONS/CP_Presentation3_CHAI_updated.pptx
+++ b/ZenabuPhD/COMMUNITY PROTECTION/PRESENTATIONS/CP_Presentation3_CHAI_updated.pptx
@@ -255,7 +255,7 @@
           <a:p>
             <a:fld id="{E7F142B0-B91C-4CEB-A596-BAFBF7C16CA8}" type="datetimeFigureOut">
               <a:rPr lang="de-CH" smtClean="0"/>
-              <a:t>26.05.2026</a:t>
+              <a:t>28.05.2026</a:t>
             </a:fld>
             <a:endParaRPr lang="de-CH"/>
           </a:p>
@@ -432,7 +432,7 @@
           <a:p>
             <a:fld id="{1AD84D78-5243-4D95-A46D-1A2BEC34DE8C}" type="datetimeFigureOut">
               <a:rPr lang="de-CH" smtClean="0"/>
-              <a:t>26.05.2026</a:t>
+              <a:t>28.05.2026</a:t>
             </a:fld>
             <a:endParaRPr lang="de-CH"/>
           </a:p>
@@ -17014,7 +17014,7 @@
           <a:p>
             <a:r>
               <a:rPr lang="en-US" dirty="0"/>
-              <a:t>9</a:t>
+              <a:t>19</a:t>
             </a:r>
             <a:r>
               <a:rPr lang="en-US" baseline="30000" dirty="0"/>
@@ -17022,7 +17022,7 @@
             </a:r>
             <a:r>
               <a:rPr lang="en-US" dirty="0"/>
-              <a:t> June, 2026</a:t>
+              <a:t> May, 2026</a:t>
             </a:r>
             <a:endParaRPr lang="de-CH" dirty="0"/>
           </a:p>
@@ -33929,6 +33929,15 @@
 </file>
 
 <file path=customXml/item1.xml><?xml version="1.0" encoding="utf-8"?>
+<?mso-contentType ?>
+<FormTemplates xmlns="http://schemas.microsoft.com/sharepoint/v3/contenttype/forms">
+  <Display>DocumentLibraryForm</Display>
+  <Edit>DocumentLibraryForm</Edit>
+  <New>DocumentLibraryForm</New>
+</FormTemplates>
+</file>
+
+<file path=customXml/item2.xml><?xml version="1.0" encoding="utf-8"?>
 <p:properties xmlns:p="http://schemas.microsoft.com/office/2006/metadata/properties" xmlns:xsi="http://www.w3.org/2001/XMLSchema-instance" xmlns:pc="http://schemas.microsoft.com/office/infopath/2007/PartnerControls">
   <documentManagement>
     <TaxCatchAll xmlns="50ba1161-8fcf-4648-a98a-8cbde4cee383" xsi:nil="true"/>
@@ -33937,15 +33946,6 @@
     </lcf76f155ced4ddcb4097134ff3c332f>
   </documentManagement>
 </p:properties>
-</file>
-
-<file path=customXml/item2.xml><?xml version="1.0" encoding="utf-8"?>
-<?mso-contentType ?>
-<FormTemplates xmlns="http://schemas.microsoft.com/sharepoint/v3/contenttype/forms">
-  <Display>DocumentLibraryForm</Display>
-  <Edit>DocumentLibraryForm</Edit>
-  <New>DocumentLibraryForm</New>
-</FormTemplates>
 </file>
 
 <file path=customXml/item3.xml><?xml version="1.0" encoding="utf-8"?>
@@ -34150,6 +34150,14 @@
 </file>
 
 <file path=customXml/itemProps1.xml><?xml version="1.0" encoding="utf-8"?>
+<ds:datastoreItem xmlns:ds="http://schemas.openxmlformats.org/officeDocument/2006/customXml" ds:itemID="{D55AE8BB-A4BB-4E89-B55D-B4E560473032}">
+  <ds:schemaRefs>
+    <ds:schemaRef ds:uri="http://schemas.microsoft.com/sharepoint/v3/contenttype/forms"/>
+  </ds:schemaRefs>
+</ds:datastoreItem>
+</file>
+
+<file path=customXml/itemProps2.xml><?xml version="1.0" encoding="utf-8"?>
 <ds:datastoreItem xmlns:ds="http://schemas.openxmlformats.org/officeDocument/2006/customXml" ds:itemID="{5710BB5C-7355-4D41-B1BB-CFD6F211FEDD}">
   <ds:schemaRefs>
     <ds:schemaRef ds:uri="http://schemas.microsoft.com/office/2006/documentManagement/types"/>
@@ -34162,14 +34170,6 @@
     <ds:schemaRef ds:uri="http://www.w3.org/XML/1998/namespace"/>
     <ds:schemaRef ds:uri="http://purl.org/dc/terms/"/>
     <ds:schemaRef ds:uri="http://purl.org/dc/elements/1.1/"/>
-  </ds:schemaRefs>
-</ds:datastoreItem>
-</file>
-
-<file path=customXml/itemProps2.xml><?xml version="1.0" encoding="utf-8"?>
-<ds:datastoreItem xmlns:ds="http://schemas.openxmlformats.org/officeDocument/2006/customXml" ds:itemID="{D55AE8BB-A4BB-4E89-B55D-B4E560473032}">
-  <ds:schemaRefs>
-    <ds:schemaRef ds:uri="http://schemas.microsoft.com/sharepoint/v3/contenttype/forms"/>
   </ds:schemaRefs>
 </ds:datastoreItem>
 </file>

</xml_diff>